<commit_message>
slides: add union-find chain inset to the single-core slide
Adds a graph inset beside the sequence bars: nodes A-B-C-D with consecutive solid
'tie' edges (matching the shifting homology blocks) and the A...D dashed NON-edge,
labelled '1 connected component = ONE family' — making the transitive-closure
point explicit (A and D are in one family with no direct tie and no common core).

Co-Authored-By: Claude Opus 4.8 (1M context) <noreply@anthropic.com>
Claude-Session: https://claude.ai/code/session_018funJhdseQMj6htigjdqhk
</commit_message>
<xml_diff>
--- a/bench/slides/three_slides.pptx
+++ b/bench/slides/three_slides.pptx
@@ -8,6 +8,7 @@
     <p:sldId id="256" r:id="rId7"/>
     <p:sldId id="257" r:id="rId8"/>
     <p:sldId id="258" r:id="rId9"/>
+    <p:sldId id="259" r:id="rId10"/>
   </p:sldIdLst>
   <p:sldSz cx="12191695" cy="6858000" type="screen4x3"/>
   <p:notesSz cx="6858000" cy="9144000"/>
@@ -3229,7 +3230,83 @@
                   <a:srgbClr val="14285A"/>
                 </a:solidFill>
               </a:rPr>
-              <a:t>2 · Methods to detect multi-copy gene families (gathered)</a:t>
+              <a:t>2 · Why a single common core can't discover all members</a:t>
+            </a:r>
+          </a:p>
+        </p:txBody>
+      </p:sp>
+      <p:pic>
+        <p:nvPicPr>
+          <p:cNvPr id="3" name="Picture 2" descr="s_singlecore.png"/>
+          <p:cNvPicPr>
+            <a:picLocks noChangeAspect="1"/>
+          </p:cNvPicPr>
+          <p:nvPr/>
+        </p:nvPicPr>
+        <p:blipFill>
+          <a:blip r:embed="rId2"/>
+          <a:stretch>
+            <a:fillRect/>
+          </a:stretch>
+        </p:blipFill>
+        <p:spPr>
+          <a:xfrm>
+            <a:off x="700887" y="1280160"/>
+            <a:ext cx="10789920" cy="4445311"/>
+          </a:xfrm>
+          <a:prstGeom prst="rect">
+            <a:avLst/>
+          </a:prstGeom>
+        </p:spPr>
+      </p:pic>
+    </p:spTree>
+  </p:cSld>
+  <p:clrMapOvr>
+    <a:masterClrMapping/>
+  </p:clrMapOvr>
+</p:sld>
+</file>
+
+<file path=ppt/slides/slide3.xml><?xml version="1.0" encoding="utf-8"?>
+<p:sld xmlns:a="http://schemas.openxmlformats.org/drawingml/2006/main" xmlns:p="http://schemas.openxmlformats.org/presentationml/2006/main" xmlns:r="http://schemas.openxmlformats.org/officeDocument/2006/relationships">
+  <p:cSld>
+    <p:spTree>
+      <p:nvGrpSpPr>
+        <p:cNvPr id="1" name=""/>
+        <p:cNvGrpSpPr/>
+        <p:nvPr/>
+      </p:nvGrpSpPr>
+      <p:grpSpPr/>
+      <p:sp>
+        <p:nvSpPr>
+          <p:cNvPr id="2" name="TextBox 1"/>
+          <p:cNvSpPr txBox="1"/>
+          <p:nvPr/>
+        </p:nvSpPr>
+        <p:spPr>
+          <a:xfrm>
+            <a:off x="548640" y="256032"/>
+            <a:ext cx="11064240" cy="914400"/>
+          </a:xfrm>
+          <a:prstGeom prst="rect">
+            <a:avLst/>
+          </a:prstGeom>
+          <a:noFill/>
+        </p:spPr>
+        <p:txBody>
+          <a:bodyPr wrap="square">
+            <a:spAutoFit/>
+          </a:bodyPr>
+          <a:lstStyle/>
+          <a:p>
+            <a:pPr algn="l"/>
+            <a:r>
+              <a:rPr sz="2800" b="1" i="0">
+                <a:solidFill>
+                  <a:srgbClr val="14285A"/>
+                </a:solidFill>
+              </a:rPr>
+              <a:t>3 · Methods to detect multi-copy gene families (gathered)</a:t>
             </a:r>
           </a:p>
         </p:txBody>
@@ -4176,7 +4253,7 @@
 </p:sld>
 </file>
 
-<file path=ppt/slides/slide3.xml><?xml version="1.0" encoding="utf-8"?>
+<file path=ppt/slides/slide4.xml><?xml version="1.0" encoding="utf-8"?>
 <p:sld xmlns:a="http://schemas.openxmlformats.org/drawingml/2006/main" xmlns:p="http://schemas.openxmlformats.org/presentationml/2006/main" xmlns:r="http://schemas.openxmlformats.org/officeDocument/2006/relationships">
   <p:cSld>
     <p:spTree>
@@ -4215,7 +4292,7 @@
                   <a:srgbClr val="14285A"/>
                 </a:solidFill>
               </a:rPr>
-              <a:t>3 · A runaway read can't wrongly extend the intron chain</a:t>
+              <a:t>4 · A runaway read can't wrongly extend the intron chain</a:t>
             </a:r>
           </a:p>
         </p:txBody>

</xml_diff>